<commit_message>
chore(pm): SP-76 backlog board export and the status deck
A second board export beside the first, kept as a separate file rather than
appended so the original import stays exactly what was loaded on the first
pass. shiftpay-jira-import-backlog.csv holds SP-115 to SP-122, the eight items
raised between 7 and 14 Sep. The handover walkthrough has to show them as known
and unbuilt, rather than leave the client to discover them.

The status deck's harness line drops its closed "1 May - 25 Aug" range. That
work still has open items and did not end on 25 Aug.
</commit_message>
<xml_diff>
--- a/Project Management/ShiftPay-Status-Deck.pptx
+++ b/Project Management/ShiftPay-Status-Deck.pptx
@@ -5,12 +5,12 @@
     <p:sldMasterId id="2147483648" r:id="rId1"/>
   </p:sldMasterIdLst>
   <p:sldIdLst>
-    <p:sldId id="256" r:id="rId7"/>
-    <p:sldId id="257" r:id="rId8"/>
-    <p:sldId id="258" r:id="rId9"/>
-    <p:sldId id="259" r:id="rId10"/>
+    <p:sldId id="256" r:id="rId2"/>
+    <p:sldId id="257" r:id="rId3"/>
+    <p:sldId id="258" r:id="rId4"/>
+    <p:sldId id="259" r:id="rId5"/>
   </p:sldIdLst>
-  <p:sldSz cx="12191695" cy="6858000" type="screen4x3"/>
+  <p:sldSz cx="12192000" cy="6858000"/>
   <p:notesSz cx="6858000" cy="9144000"/>
   <p:defaultTextStyle>
     <a:defPPr>
@@ -107,6 +107,22 @@
       </a:defRPr>
     </a:lvl9pPr>
   </p:defaultTextStyle>
+  <p:extLst>
+    <p:ext uri="{EFAFB233-063F-42B5-8137-9DF3F51BA10A}">
+      <p15:sldGuideLst xmlns:p15="http://schemas.microsoft.com/office/powerpoint/2012/main">
+        <p15:guide id="1" orient="horz" pos="2160">
+          <p15:clr>
+            <a:srgbClr val="A4A3A4"/>
+          </p15:clr>
+        </p15:guide>
+        <p15:guide id="2" pos="2880">
+          <p15:clr>
+            <a:srgbClr val="A4A3A4"/>
+          </p15:clr>
+        </p15:guide>
+      </p15:sldGuideLst>
+    </p:ext>
+  </p:extLst>
 </p:presentation>
 </file>
 
@@ -148,10 +164,9 @@
           <a:lstStyle/>
           <a:p>
             <a:r>
-              <a:rPr lang="en-US" smtClean="0"/>
+              <a:rPr lang="en-US"/>
               <a:t>Click to edit Master title style</a:t>
             </a:r>
-            <a:endParaRPr lang="en-US"/>
           </a:p>
         </p:txBody>
       </p:sp>
@@ -267,10 +282,9 @@
           </a:lstStyle>
           <a:p>
             <a:r>
-              <a:rPr lang="en-US" smtClean="0"/>
+              <a:rPr lang="en-US"/>
               <a:t>Click to edit Master subtitle style</a:t>
             </a:r>
-            <a:endParaRPr lang="en-US"/>
           </a:p>
         </p:txBody>
       </p:sp>
@@ -291,7 +305,7 @@
           <a:p>
             <a:fld id="{5BCAD085-E8A6-8845-BD4E-CB4CCA059FC4}" type="datetimeFigureOut">
               <a:rPr lang="en-US" smtClean="0"/>
-              <a:t>1/27/13</a:t>
+              <a:t>9/7/2026</a:t>
             </a:fld>
             <a:endParaRPr lang="en-US"/>
           </a:p>
@@ -385,10 +399,9 @@
           <a:lstStyle/>
           <a:p>
             <a:r>
-              <a:rPr lang="en-US" smtClean="0"/>
+              <a:rPr lang="en-US"/>
               <a:t>Click to edit Master title style</a:t>
             </a:r>
-            <a:endParaRPr lang="en-US"/>
           </a:p>
         </p:txBody>
       </p:sp>
@@ -409,38 +422,37 @@
           <a:p>
             <a:pPr lvl="0"/>
             <a:r>
-              <a:rPr lang="en-US" smtClean="0"/>
+              <a:rPr lang="en-US"/>
               <a:t>Click to edit Master text styles</a:t>
             </a:r>
           </a:p>
           <a:p>
             <a:pPr lvl="1"/>
             <a:r>
-              <a:rPr lang="en-US" smtClean="0"/>
+              <a:rPr lang="en-US"/>
               <a:t>Second level</a:t>
             </a:r>
           </a:p>
           <a:p>
             <a:pPr lvl="2"/>
             <a:r>
-              <a:rPr lang="en-US" smtClean="0"/>
+              <a:rPr lang="en-US"/>
               <a:t>Third level</a:t>
             </a:r>
           </a:p>
           <a:p>
             <a:pPr lvl="3"/>
             <a:r>
-              <a:rPr lang="en-US" smtClean="0"/>
+              <a:rPr lang="en-US"/>
               <a:t>Fourth level</a:t>
             </a:r>
           </a:p>
           <a:p>
             <a:pPr lvl="4"/>
             <a:r>
-              <a:rPr lang="en-US" smtClean="0"/>
+              <a:rPr lang="en-US"/>
               <a:t>Fifth level</a:t>
             </a:r>
-            <a:endParaRPr lang="en-US"/>
           </a:p>
         </p:txBody>
       </p:sp>
@@ -461,7 +473,7 @@
           <a:p>
             <a:fld id="{5BCAD085-E8A6-8845-BD4E-CB4CCA059FC4}" type="datetimeFigureOut">
               <a:rPr lang="en-US" smtClean="0"/>
-              <a:t>1/27/13</a:t>
+              <a:t>9/7/2026</a:t>
             </a:fld>
             <a:endParaRPr lang="en-US"/>
           </a:p>
@@ -560,10 +572,9 @@
           <a:lstStyle/>
           <a:p>
             <a:r>
-              <a:rPr lang="en-US" smtClean="0"/>
+              <a:rPr lang="en-US"/>
               <a:t>Click to edit Master title style</a:t>
             </a:r>
-            <a:endParaRPr lang="en-US"/>
           </a:p>
         </p:txBody>
       </p:sp>
@@ -589,38 +600,37 @@
           <a:p>
             <a:pPr lvl="0"/>
             <a:r>
-              <a:rPr lang="en-US" smtClean="0"/>
+              <a:rPr lang="en-US"/>
               <a:t>Click to edit Master text styles</a:t>
             </a:r>
           </a:p>
           <a:p>
             <a:pPr lvl="1"/>
             <a:r>
-              <a:rPr lang="en-US" smtClean="0"/>
+              <a:rPr lang="en-US"/>
               <a:t>Second level</a:t>
             </a:r>
           </a:p>
           <a:p>
             <a:pPr lvl="2"/>
             <a:r>
-              <a:rPr lang="en-US" smtClean="0"/>
+              <a:rPr lang="en-US"/>
               <a:t>Third level</a:t>
             </a:r>
           </a:p>
           <a:p>
             <a:pPr lvl="3"/>
             <a:r>
-              <a:rPr lang="en-US" smtClean="0"/>
+              <a:rPr lang="en-US"/>
               <a:t>Fourth level</a:t>
             </a:r>
           </a:p>
           <a:p>
             <a:pPr lvl="4"/>
             <a:r>
-              <a:rPr lang="en-US" smtClean="0"/>
+              <a:rPr lang="en-US"/>
               <a:t>Fifth level</a:t>
             </a:r>
-            <a:endParaRPr lang="en-US"/>
           </a:p>
         </p:txBody>
       </p:sp>
@@ -641,7 +651,7 @@
           <a:p>
             <a:fld id="{5BCAD085-E8A6-8845-BD4E-CB4CCA059FC4}" type="datetimeFigureOut">
               <a:rPr lang="en-US" smtClean="0"/>
-              <a:t>1/27/13</a:t>
+              <a:t>9/7/2026</a:t>
             </a:fld>
             <a:endParaRPr lang="en-US"/>
           </a:p>
@@ -735,10 +745,9 @@
           <a:lstStyle/>
           <a:p>
             <a:r>
-              <a:rPr lang="en-US" smtClean="0"/>
+              <a:rPr lang="en-US"/>
               <a:t>Click to edit Master title style</a:t>
             </a:r>
-            <a:endParaRPr lang="en-US"/>
           </a:p>
         </p:txBody>
       </p:sp>
@@ -759,38 +768,37 @@
           <a:p>
             <a:pPr lvl="0"/>
             <a:r>
-              <a:rPr lang="en-US" smtClean="0"/>
+              <a:rPr lang="en-US"/>
               <a:t>Click to edit Master text styles</a:t>
             </a:r>
           </a:p>
           <a:p>
             <a:pPr lvl="1"/>
             <a:r>
-              <a:rPr lang="en-US" smtClean="0"/>
+              <a:rPr lang="en-US"/>
               <a:t>Second level</a:t>
             </a:r>
           </a:p>
           <a:p>
             <a:pPr lvl="2"/>
             <a:r>
-              <a:rPr lang="en-US" smtClean="0"/>
+              <a:rPr lang="en-US"/>
               <a:t>Third level</a:t>
             </a:r>
           </a:p>
           <a:p>
             <a:pPr lvl="3"/>
             <a:r>
-              <a:rPr lang="en-US" smtClean="0"/>
+              <a:rPr lang="en-US"/>
               <a:t>Fourth level</a:t>
             </a:r>
           </a:p>
           <a:p>
             <a:pPr lvl="4"/>
             <a:r>
-              <a:rPr lang="en-US" smtClean="0"/>
+              <a:rPr lang="en-US"/>
               <a:t>Fifth level</a:t>
             </a:r>
-            <a:endParaRPr lang="en-US"/>
           </a:p>
         </p:txBody>
       </p:sp>
@@ -811,7 +819,7 @@
           <a:p>
             <a:fld id="{5BCAD085-E8A6-8845-BD4E-CB4CCA059FC4}" type="datetimeFigureOut">
               <a:rPr lang="en-US" smtClean="0"/>
-              <a:t>1/27/13</a:t>
+              <a:t>9/7/2026</a:t>
             </a:fld>
             <a:endParaRPr lang="en-US"/>
           </a:p>
@@ -914,10 +922,9 @@
           </a:lstStyle>
           <a:p>
             <a:r>
-              <a:rPr lang="en-US" smtClean="0"/>
+              <a:rPr lang="en-US"/>
               <a:t>Click to edit Master title style</a:t>
             </a:r>
-            <a:endParaRPr lang="en-US"/>
           </a:p>
         </p:txBody>
       </p:sp>
@@ -1034,7 +1041,7 @@
           <a:p>
             <a:pPr lvl="0"/>
             <a:r>
-              <a:rPr lang="en-US" smtClean="0"/>
+              <a:rPr lang="en-US"/>
               <a:t>Click to edit Master text styles</a:t>
             </a:r>
           </a:p>
@@ -1057,7 +1064,7 @@
           <a:p>
             <a:fld id="{5BCAD085-E8A6-8845-BD4E-CB4CCA059FC4}" type="datetimeFigureOut">
               <a:rPr lang="en-US" smtClean="0"/>
-              <a:t>1/27/13</a:t>
+              <a:t>9/7/2026</a:t>
             </a:fld>
             <a:endParaRPr lang="en-US"/>
           </a:p>
@@ -1151,10 +1158,9 @@
           <a:lstStyle/>
           <a:p>
             <a:r>
-              <a:rPr lang="en-US" smtClean="0"/>
+              <a:rPr lang="en-US"/>
               <a:t>Click to edit Master title style</a:t>
             </a:r>
-            <a:endParaRPr lang="en-US"/>
           </a:p>
         </p:txBody>
       </p:sp>
@@ -1208,38 +1214,37 @@
           <a:p>
             <a:pPr lvl="0"/>
             <a:r>
-              <a:rPr lang="en-US" smtClean="0"/>
+              <a:rPr lang="en-US"/>
               <a:t>Click to edit Master text styles</a:t>
             </a:r>
           </a:p>
           <a:p>
             <a:pPr lvl="1"/>
             <a:r>
-              <a:rPr lang="en-US" smtClean="0"/>
+              <a:rPr lang="en-US"/>
               <a:t>Second level</a:t>
             </a:r>
           </a:p>
           <a:p>
             <a:pPr lvl="2"/>
             <a:r>
-              <a:rPr lang="en-US" smtClean="0"/>
+              <a:rPr lang="en-US"/>
               <a:t>Third level</a:t>
             </a:r>
           </a:p>
           <a:p>
             <a:pPr lvl="3"/>
             <a:r>
-              <a:rPr lang="en-US" smtClean="0"/>
+              <a:rPr lang="en-US"/>
               <a:t>Fourth level</a:t>
             </a:r>
           </a:p>
           <a:p>
             <a:pPr lvl="4"/>
             <a:r>
-              <a:rPr lang="en-US" smtClean="0"/>
+              <a:rPr lang="en-US"/>
               <a:t>Fifth level</a:t>
             </a:r>
-            <a:endParaRPr lang="en-US"/>
           </a:p>
         </p:txBody>
       </p:sp>
@@ -1293,38 +1298,37 @@
           <a:p>
             <a:pPr lvl="0"/>
             <a:r>
-              <a:rPr lang="en-US" smtClean="0"/>
+              <a:rPr lang="en-US"/>
               <a:t>Click to edit Master text styles</a:t>
             </a:r>
           </a:p>
           <a:p>
             <a:pPr lvl="1"/>
             <a:r>
-              <a:rPr lang="en-US" smtClean="0"/>
+              <a:rPr lang="en-US"/>
               <a:t>Second level</a:t>
             </a:r>
           </a:p>
           <a:p>
             <a:pPr lvl="2"/>
             <a:r>
-              <a:rPr lang="en-US" smtClean="0"/>
+              <a:rPr lang="en-US"/>
               <a:t>Third level</a:t>
             </a:r>
           </a:p>
           <a:p>
             <a:pPr lvl="3"/>
             <a:r>
-              <a:rPr lang="en-US" smtClean="0"/>
+              <a:rPr lang="en-US"/>
               <a:t>Fourth level</a:t>
             </a:r>
           </a:p>
           <a:p>
             <a:pPr lvl="4"/>
             <a:r>
-              <a:rPr lang="en-US" smtClean="0"/>
+              <a:rPr lang="en-US"/>
               <a:t>Fifth level</a:t>
             </a:r>
-            <a:endParaRPr lang="en-US"/>
           </a:p>
         </p:txBody>
       </p:sp>
@@ -1345,7 +1349,7 @@
           <a:p>
             <a:fld id="{5BCAD085-E8A6-8845-BD4E-CB4CCA059FC4}" type="datetimeFigureOut">
               <a:rPr lang="en-US" smtClean="0"/>
-              <a:t>1/27/13</a:t>
+              <a:t>9/7/2026</a:t>
             </a:fld>
             <a:endParaRPr lang="en-US"/>
           </a:p>
@@ -1443,10 +1447,9 @@
           </a:lstStyle>
           <a:p>
             <a:r>
-              <a:rPr lang="en-US" smtClean="0"/>
+              <a:rPr lang="en-US"/>
               <a:t>Click to edit Master title style</a:t>
             </a:r>
-            <a:endParaRPr lang="en-US"/>
           </a:p>
         </p:txBody>
       </p:sp>
@@ -1509,7 +1512,7 @@
           <a:p>
             <a:pPr lvl="0"/>
             <a:r>
-              <a:rPr lang="en-US" smtClean="0"/>
+              <a:rPr lang="en-US"/>
               <a:t>Click to edit Master text styles</a:t>
             </a:r>
           </a:p>
@@ -1565,38 +1568,37 @@
           <a:p>
             <a:pPr lvl="0"/>
             <a:r>
-              <a:rPr lang="en-US" smtClean="0"/>
+              <a:rPr lang="en-US"/>
               <a:t>Click to edit Master text styles</a:t>
             </a:r>
           </a:p>
           <a:p>
             <a:pPr lvl="1"/>
             <a:r>
-              <a:rPr lang="en-US" smtClean="0"/>
+              <a:rPr lang="en-US"/>
               <a:t>Second level</a:t>
             </a:r>
           </a:p>
           <a:p>
             <a:pPr lvl="2"/>
             <a:r>
-              <a:rPr lang="en-US" smtClean="0"/>
+              <a:rPr lang="en-US"/>
               <a:t>Third level</a:t>
             </a:r>
           </a:p>
           <a:p>
             <a:pPr lvl="3"/>
             <a:r>
-              <a:rPr lang="en-US" smtClean="0"/>
+              <a:rPr lang="en-US"/>
               <a:t>Fourth level</a:t>
             </a:r>
           </a:p>
           <a:p>
             <a:pPr lvl="4"/>
             <a:r>
-              <a:rPr lang="en-US" smtClean="0"/>
+              <a:rPr lang="en-US"/>
               <a:t>Fifth level</a:t>
             </a:r>
-            <a:endParaRPr lang="en-US"/>
           </a:p>
         </p:txBody>
       </p:sp>
@@ -1659,7 +1661,7 @@
           <a:p>
             <a:pPr lvl="0"/>
             <a:r>
-              <a:rPr lang="en-US" smtClean="0"/>
+              <a:rPr lang="en-US"/>
               <a:t>Click to edit Master text styles</a:t>
             </a:r>
           </a:p>
@@ -1715,38 +1717,37 @@
           <a:p>
             <a:pPr lvl="0"/>
             <a:r>
-              <a:rPr lang="en-US" smtClean="0"/>
+              <a:rPr lang="en-US"/>
               <a:t>Click to edit Master text styles</a:t>
             </a:r>
           </a:p>
           <a:p>
             <a:pPr lvl="1"/>
             <a:r>
-              <a:rPr lang="en-US" smtClean="0"/>
+              <a:rPr lang="en-US"/>
               <a:t>Second level</a:t>
             </a:r>
           </a:p>
           <a:p>
             <a:pPr lvl="2"/>
             <a:r>
-              <a:rPr lang="en-US" smtClean="0"/>
+              <a:rPr lang="en-US"/>
               <a:t>Third level</a:t>
             </a:r>
           </a:p>
           <a:p>
             <a:pPr lvl="3"/>
             <a:r>
-              <a:rPr lang="en-US" smtClean="0"/>
+              <a:rPr lang="en-US"/>
               <a:t>Fourth level</a:t>
             </a:r>
           </a:p>
           <a:p>
             <a:pPr lvl="4"/>
             <a:r>
-              <a:rPr lang="en-US" smtClean="0"/>
+              <a:rPr lang="en-US"/>
               <a:t>Fifth level</a:t>
             </a:r>
-            <a:endParaRPr lang="en-US"/>
           </a:p>
         </p:txBody>
       </p:sp>
@@ -1767,7 +1768,7 @@
           <a:p>
             <a:fld id="{5BCAD085-E8A6-8845-BD4E-CB4CCA059FC4}" type="datetimeFigureOut">
               <a:rPr lang="en-US" smtClean="0"/>
-              <a:t>1/27/13</a:t>
+              <a:t>9/7/2026</a:t>
             </a:fld>
             <a:endParaRPr lang="en-US"/>
           </a:p>
@@ -1861,10 +1862,9 @@
           <a:lstStyle/>
           <a:p>
             <a:r>
-              <a:rPr lang="en-US" smtClean="0"/>
+              <a:rPr lang="en-US"/>
               <a:t>Click to edit Master title style</a:t>
             </a:r>
-            <a:endParaRPr lang="en-US"/>
           </a:p>
         </p:txBody>
       </p:sp>
@@ -1885,7 +1885,7 @@
           <a:p>
             <a:fld id="{5BCAD085-E8A6-8845-BD4E-CB4CCA059FC4}" type="datetimeFigureOut">
               <a:rPr lang="en-US" smtClean="0"/>
-              <a:t>1/27/13</a:t>
+              <a:t>9/7/2026</a:t>
             </a:fld>
             <a:endParaRPr lang="en-US"/>
           </a:p>
@@ -1980,7 +1980,7 @@
           <a:p>
             <a:fld id="{5BCAD085-E8A6-8845-BD4E-CB4CCA059FC4}" type="datetimeFigureOut">
               <a:rPr lang="en-US" smtClean="0"/>
-              <a:t>1/27/13</a:t>
+              <a:t>9/7/2026</a:t>
             </a:fld>
             <a:endParaRPr lang="en-US"/>
           </a:p>
@@ -2083,10 +2083,9 @@
           </a:lstStyle>
           <a:p>
             <a:r>
-              <a:rPr lang="en-US" smtClean="0"/>
+              <a:rPr lang="en-US"/>
               <a:t>Click to edit Master title style</a:t>
             </a:r>
-            <a:endParaRPr lang="en-US"/>
           </a:p>
         </p:txBody>
       </p:sp>
@@ -2140,38 +2139,37 @@
           <a:p>
             <a:pPr lvl="0"/>
             <a:r>
-              <a:rPr lang="en-US" smtClean="0"/>
+              <a:rPr lang="en-US"/>
               <a:t>Click to edit Master text styles</a:t>
             </a:r>
           </a:p>
           <a:p>
             <a:pPr lvl="1"/>
             <a:r>
-              <a:rPr lang="en-US" smtClean="0"/>
+              <a:rPr lang="en-US"/>
               <a:t>Second level</a:t>
             </a:r>
           </a:p>
           <a:p>
             <a:pPr lvl="2"/>
             <a:r>
-              <a:rPr lang="en-US" smtClean="0"/>
+              <a:rPr lang="en-US"/>
               <a:t>Third level</a:t>
             </a:r>
           </a:p>
           <a:p>
             <a:pPr lvl="3"/>
             <a:r>
-              <a:rPr lang="en-US" smtClean="0"/>
+              <a:rPr lang="en-US"/>
               <a:t>Fourth level</a:t>
             </a:r>
           </a:p>
           <a:p>
             <a:pPr lvl="4"/>
             <a:r>
-              <a:rPr lang="en-US" smtClean="0"/>
+              <a:rPr lang="en-US"/>
               <a:t>Fifth level</a:t>
             </a:r>
-            <a:endParaRPr lang="en-US"/>
           </a:p>
         </p:txBody>
       </p:sp>
@@ -2234,7 +2232,7 @@
           <a:p>
             <a:pPr lvl="0"/>
             <a:r>
-              <a:rPr lang="en-US" smtClean="0"/>
+              <a:rPr lang="en-US"/>
               <a:t>Click to edit Master text styles</a:t>
             </a:r>
           </a:p>
@@ -2257,7 +2255,7 @@
           <a:p>
             <a:fld id="{5BCAD085-E8A6-8845-BD4E-CB4CCA059FC4}" type="datetimeFigureOut">
               <a:rPr lang="en-US" smtClean="0"/>
-              <a:t>1/27/13</a:t>
+              <a:t>9/7/2026</a:t>
             </a:fld>
             <a:endParaRPr lang="en-US"/>
           </a:p>
@@ -2360,10 +2358,9 @@
           </a:lstStyle>
           <a:p>
             <a:r>
-              <a:rPr lang="en-US" smtClean="0"/>
+              <a:rPr lang="en-US"/>
               <a:t>Click to edit Master title style</a:t>
             </a:r>
-            <a:endParaRPr lang="en-US"/>
           </a:p>
         </p:txBody>
       </p:sp>
@@ -2487,7 +2484,7 @@
           <a:p>
             <a:pPr lvl="0"/>
             <a:r>
-              <a:rPr lang="en-US" smtClean="0"/>
+              <a:rPr lang="en-US"/>
               <a:t>Click to edit Master text styles</a:t>
             </a:r>
           </a:p>
@@ -2510,7 +2507,7 @@
           <a:p>
             <a:fld id="{5BCAD085-E8A6-8845-BD4E-CB4CCA059FC4}" type="datetimeFigureOut">
               <a:rPr lang="en-US" smtClean="0"/>
-              <a:t>1/27/13</a:t>
+              <a:t>9/7/2026</a:t>
             </a:fld>
             <a:endParaRPr lang="en-US"/>
           </a:p>
@@ -2619,10 +2616,9 @@
           <a:lstStyle/>
           <a:p>
             <a:r>
-              <a:rPr lang="en-US" smtClean="0"/>
+              <a:rPr lang="en-US"/>
               <a:t>Click to edit Master title style</a:t>
             </a:r>
-            <a:endParaRPr lang="en-US"/>
           </a:p>
         </p:txBody>
       </p:sp>
@@ -2653,38 +2649,37 @@
           <a:p>
             <a:pPr lvl="0"/>
             <a:r>
-              <a:rPr lang="en-US" smtClean="0"/>
+              <a:rPr lang="en-US"/>
               <a:t>Click to edit Master text styles</a:t>
             </a:r>
           </a:p>
           <a:p>
             <a:pPr lvl="1"/>
             <a:r>
-              <a:rPr lang="en-US" smtClean="0"/>
+              <a:rPr lang="en-US"/>
               <a:t>Second level</a:t>
             </a:r>
           </a:p>
           <a:p>
             <a:pPr lvl="2"/>
             <a:r>
-              <a:rPr lang="en-US" smtClean="0"/>
+              <a:rPr lang="en-US"/>
               <a:t>Third level</a:t>
             </a:r>
           </a:p>
           <a:p>
             <a:pPr lvl="3"/>
             <a:r>
-              <a:rPr lang="en-US" smtClean="0"/>
+              <a:rPr lang="en-US"/>
               <a:t>Fourth level</a:t>
             </a:r>
           </a:p>
           <a:p>
             <a:pPr lvl="4"/>
             <a:r>
-              <a:rPr lang="en-US" smtClean="0"/>
+              <a:rPr lang="en-US"/>
               <a:t>Fifth level</a:t>
             </a:r>
-            <a:endParaRPr lang="en-US"/>
           </a:p>
         </p:txBody>
       </p:sp>
@@ -2723,7 +2718,7 @@
           <a:p>
             <a:fld id="{5BCAD085-E8A6-8845-BD4E-CB4CCA059FC4}" type="datetimeFigureOut">
               <a:rPr lang="en-US" smtClean="0"/>
-              <a:t>1/27/13</a:t>
+              <a:t>9/7/2026</a:t>
             </a:fld>
             <a:endParaRPr lang="en-US"/>
           </a:p>
@@ -3082,7 +3077,7 @@
 </file>
 
 <file path=ppt/slides/slide1.xml><?xml version="1.0" encoding="utf-8"?>
-<p:sld xmlns:a="http://schemas.openxmlformats.org/drawingml/2006/main" xmlns:p="http://schemas.openxmlformats.org/presentationml/2006/main" xmlns:r="http://schemas.openxmlformats.org/officeDocument/2006/relationships">
+<p:sld xmlns:a="http://schemas.openxmlformats.org/drawingml/2006/main" xmlns:r="http://schemas.openxmlformats.org/officeDocument/2006/relationships" xmlns:p="http://schemas.openxmlformats.org/presentationml/2006/main">
   <p:cSld>
     <p:spTree>
       <p:nvGrpSpPr>
@@ -3090,7 +3085,14 @@
         <p:cNvGrpSpPr/>
         <p:nvPr/>
       </p:nvGrpSpPr>
-      <p:grpSpPr/>
+      <p:grpSpPr>
+        <a:xfrm>
+          <a:off x="0" y="0"/>
+          <a:ext cx="0" cy="0"/>
+          <a:chOff x="0" y="0"/>
+          <a:chExt cx="0" cy="0"/>
+        </a:xfrm>
+      </p:grpSpPr>
       <p:sp>
         <p:nvSpPr>
           <p:cNvPr id="2" name="Rectangle 1"/>
@@ -3132,6 +3134,7 @@
           <a:lstStyle/>
           <a:p>
             <a:pPr algn="ctr"/>
+            <a:endParaRPr/>
           </a:p>
         </p:txBody>
       </p:sp>
@@ -3152,7 +3155,7 @@
           <a:noFill/>
         </p:spPr>
         <p:txBody>
-          <a:bodyPr wrap="square" anchor="t" lIns="0" rIns="0" tIns="0" bIns="0">
+          <a:bodyPr wrap="square" lIns="0" tIns="0" rIns="0" bIns="0" anchor="t">
             <a:spAutoFit/>
           </a:bodyPr>
           <a:lstStyle/>
@@ -3191,7 +3194,7 @@
           <a:noFill/>
         </p:spPr>
         <p:txBody>
-          <a:bodyPr wrap="square" anchor="t" lIns="0" rIns="0" tIns="0" bIns="0">
+          <a:bodyPr wrap="square" lIns="0" tIns="0" rIns="0" bIns="0" anchor="t">
             <a:spAutoFit/>
           </a:bodyPr>
           <a:lstStyle/>
@@ -3254,6 +3257,7 @@
           <a:lstStyle/>
           <a:p>
             <a:pPr algn="ctr"/>
+            <a:endParaRPr/>
           </a:p>
         </p:txBody>
       </p:sp>
@@ -3274,7 +3278,7 @@
           <a:noFill/>
         </p:spPr>
         <p:txBody>
-          <a:bodyPr wrap="square" anchor="t" lIns="0" rIns="0" tIns="0" bIns="0">
+          <a:bodyPr wrap="square" lIns="0" tIns="0" rIns="0" bIns="0" anchor="t">
             <a:spAutoFit/>
           </a:bodyPr>
           <a:lstStyle/>
@@ -3337,6 +3341,7 @@
           <a:lstStyle/>
           <a:p>
             <a:pPr algn="ctr"/>
+            <a:endParaRPr/>
           </a:p>
         </p:txBody>
       </p:sp>
@@ -3357,7 +3362,7 @@
           <a:noFill/>
         </p:spPr>
         <p:txBody>
-          <a:bodyPr wrap="square" anchor="t" lIns="0" rIns="0" tIns="0" bIns="0">
+          <a:bodyPr wrap="square" lIns="0" tIns="0" rIns="0" bIns="0" anchor="t">
             <a:spAutoFit/>
           </a:bodyPr>
           <a:lstStyle/>
@@ -3396,7 +3401,7 @@
           <a:noFill/>
         </p:spPr>
         <p:txBody>
-          <a:bodyPr wrap="square" anchor="t" lIns="0" rIns="0" tIns="0" bIns="0">
+          <a:bodyPr wrap="square" lIns="0" tIns="0" rIns="0" bIns="0" anchor="t">
             <a:spAutoFit/>
           </a:bodyPr>
           <a:lstStyle/>
@@ -3459,6 +3464,7 @@
           <a:lstStyle/>
           <a:p>
             <a:pPr algn="ctr"/>
+            <a:endParaRPr/>
           </a:p>
         </p:txBody>
       </p:sp>
@@ -3479,7 +3485,7 @@
           <a:noFill/>
         </p:spPr>
         <p:txBody>
-          <a:bodyPr wrap="square" anchor="t" lIns="0" rIns="0" tIns="0" bIns="0">
+          <a:bodyPr wrap="square" lIns="0" tIns="0" rIns="0" bIns="0" anchor="t">
             <a:spAutoFit/>
           </a:bodyPr>
           <a:lstStyle/>
@@ -3518,7 +3524,7 @@
           <a:noFill/>
         </p:spPr>
         <p:txBody>
-          <a:bodyPr wrap="square" anchor="t" lIns="0" rIns="0" tIns="0" bIns="0">
+          <a:bodyPr wrap="square" lIns="0" tIns="0" rIns="0" bIns="0" anchor="t">
             <a:spAutoFit/>
           </a:bodyPr>
           <a:lstStyle/>
@@ -3581,6 +3587,7 @@
           <a:lstStyle/>
           <a:p>
             <a:pPr algn="ctr"/>
+            <a:endParaRPr/>
           </a:p>
         </p:txBody>
       </p:sp>
@@ -3601,7 +3608,7 @@
           <a:noFill/>
         </p:spPr>
         <p:txBody>
-          <a:bodyPr wrap="square" anchor="t" lIns="0" rIns="0" tIns="0" bIns="0">
+          <a:bodyPr wrap="square" lIns="0" tIns="0" rIns="0" bIns="0" anchor="t">
             <a:spAutoFit/>
           </a:bodyPr>
           <a:lstStyle/>
@@ -3640,7 +3647,7 @@
           <a:noFill/>
         </p:spPr>
         <p:txBody>
-          <a:bodyPr wrap="square" anchor="t" lIns="0" rIns="0" tIns="0" bIns="0">
+          <a:bodyPr wrap="square" lIns="0" tIns="0" rIns="0" bIns="0" anchor="t">
             <a:spAutoFit/>
           </a:bodyPr>
           <a:lstStyle/>
@@ -3703,6 +3710,7 @@
           <a:lstStyle/>
           <a:p>
             <a:pPr algn="ctr"/>
+            <a:endParaRPr/>
           </a:p>
         </p:txBody>
       </p:sp>
@@ -3723,7 +3731,7 @@
           <a:noFill/>
         </p:spPr>
         <p:txBody>
-          <a:bodyPr wrap="square" anchor="t" lIns="0" rIns="0" tIns="0" bIns="0">
+          <a:bodyPr wrap="square" lIns="0" tIns="0" rIns="0" bIns="0" anchor="t">
             <a:spAutoFit/>
           </a:bodyPr>
           <a:lstStyle/>
@@ -3762,7 +3770,7 @@
           <a:noFill/>
         </p:spPr>
         <p:txBody>
-          <a:bodyPr wrap="square" anchor="t" lIns="0" rIns="0" tIns="0" bIns="0">
+          <a:bodyPr wrap="square" lIns="0" tIns="0" rIns="0" bIns="0" anchor="t">
             <a:spAutoFit/>
           </a:bodyPr>
           <a:lstStyle/>
@@ -3801,7 +3809,7 @@
           <a:noFill/>
         </p:spPr>
         <p:txBody>
-          <a:bodyPr wrap="square" anchor="t" lIns="0" rIns="0" tIns="0" bIns="0">
+          <a:bodyPr wrap="square" lIns="0" tIns="0" rIns="0" bIns="0" anchor="t">
             <a:spAutoFit/>
           </a:bodyPr>
           <a:lstStyle/>
@@ -3928,6 +3936,7 @@
           <a:lstStyle/>
           <a:p>
             <a:pPr algn="ctr"/>
+            <a:endParaRPr/>
           </a:p>
         </p:txBody>
       </p:sp>
@@ -3940,7 +3949,7 @@
         <p:spPr>
           <a:xfrm>
             <a:off x="6748272" y="3429000"/>
-            <a:ext cx="4572000" cy="274320"/>
+            <a:ext cx="4572000" cy="2659702"/>
           </a:xfrm>
           <a:prstGeom prst="rect">
             <a:avLst/>
@@ -3948,7 +3957,7 @@
           <a:noFill/>
         </p:spPr>
         <p:txBody>
-          <a:bodyPr wrap="square" anchor="t" lIns="0" rIns="0" tIns="0" bIns="0">
+          <a:bodyPr wrap="square" lIns="0" tIns="0" rIns="0" bIns="0" anchor="t">
             <a:spAutoFit/>
           </a:bodyPr>
           <a:lstStyle/>
@@ -3959,7 +3968,7 @@
               </a:spcAft>
             </a:pPr>
             <a:r>
-              <a:rPr sz="1200" b="1">
+              <a:rPr sz="1200" b="1" dirty="0">
                 <a:solidFill>
                   <a:srgbClr val="003654"/>
                 </a:solidFill>
@@ -3975,13 +3984,31 @@
               </a:spcAft>
             </a:pPr>
             <a:r>
-              <a:rPr sz="1050" b="1">
+              <a:rPr sz="1050" b="1" dirty="0">
                 <a:solidFill>
                   <a:srgbClr val="1A1A1A"/>
                 </a:solidFill>
                 <a:latin typeface="Calibri"/>
               </a:rPr>
-              <a:t>Geetha Nallamada  ·  Sr Data Analyst</a:t>
+              <a:t>Geetha </a:t>
+            </a:r>
+            <a:r>
+              <a:rPr sz="1050" b="1" dirty="0" err="1">
+                <a:solidFill>
+                  <a:srgbClr val="1A1A1A"/>
+                </a:solidFill>
+                <a:latin typeface="Calibri"/>
+              </a:rPr>
+              <a:t>Nallamada</a:t>
+            </a:r>
+            <a:r>
+              <a:rPr sz="1050" b="1" dirty="0">
+                <a:solidFill>
+                  <a:srgbClr val="1A1A1A"/>
+                </a:solidFill>
+                <a:latin typeface="Calibri"/>
+              </a:rPr>
+              <a:t>  ·  Sr Data Analyst</a:t>
             </a:r>
           </a:p>
           <a:p>
@@ -3991,7 +4018,7 @@
               </a:spcAft>
             </a:pPr>
             <a:r>
-              <a:rPr sz="950" b="0">
+              <a:rPr sz="950" b="0" dirty="0">
                 <a:solidFill>
                   <a:srgbClr val="606676"/>
                 </a:solidFill>
@@ -4007,7 +4034,7 @@
               </a:spcAft>
             </a:pPr>
             <a:r>
-              <a:rPr sz="1050" b="1">
+              <a:rPr sz="1050" b="1" dirty="0">
                 <a:solidFill>
                   <a:srgbClr val="1A1A1A"/>
                 </a:solidFill>
@@ -4023,7 +4050,7 @@
               </a:spcAft>
             </a:pPr>
             <a:r>
-              <a:rPr sz="950" b="0">
+              <a:rPr sz="950" b="0" dirty="0">
                 <a:solidFill>
                   <a:srgbClr val="606676"/>
                 </a:solidFill>
@@ -4039,7 +4066,7 @@
               </a:spcAft>
             </a:pPr>
             <a:r>
-              <a:rPr sz="1050" b="1">
+              <a:rPr sz="1050" b="1" dirty="0">
                 <a:solidFill>
                   <a:srgbClr val="1A1A1A"/>
                 </a:solidFill>
@@ -4055,7 +4082,7 @@
               </a:spcAft>
             </a:pPr>
             <a:r>
-              <a:rPr sz="950" b="0">
+              <a:rPr sz="950" b="0" dirty="0">
                 <a:solidFill>
                   <a:srgbClr val="606676"/>
                 </a:solidFill>
@@ -4071,7 +4098,7 @@
               </a:spcAft>
             </a:pPr>
             <a:r>
-              <a:rPr sz="1050" b="1">
+              <a:rPr sz="1050" b="1" dirty="0">
                 <a:solidFill>
                   <a:srgbClr val="1A1A1A"/>
                 </a:solidFill>
@@ -4087,7 +4114,7 @@
               </a:spcAft>
             </a:pPr>
             <a:r>
-              <a:rPr sz="950" b="0">
+              <a:rPr sz="950" b="0" dirty="0">
                 <a:solidFill>
                   <a:srgbClr val="606676"/>
                 </a:solidFill>
@@ -4103,7 +4130,7 @@
               </a:spcAft>
             </a:pPr>
             <a:r>
-              <a:rPr sz="1050" b="1">
+              <a:rPr sz="1050" b="1" dirty="0">
                 <a:solidFill>
                   <a:srgbClr val="1A1A1A"/>
                 </a:solidFill>
@@ -4119,7 +4146,7 @@
               </a:spcAft>
             </a:pPr>
             <a:r>
-              <a:rPr sz="950" b="0">
+              <a:rPr sz="950" b="0" dirty="0">
                 <a:solidFill>
                   <a:srgbClr val="606676"/>
                 </a:solidFill>
@@ -4135,13 +4162,22 @@
               </a:spcAft>
             </a:pPr>
             <a:r>
-              <a:rPr sz="1050" b="1">
+              <a:rPr sz="1050" b="1" dirty="0" err="1">
                 <a:solidFill>
                   <a:srgbClr val="1A1A1A"/>
                 </a:solidFill>
                 <a:latin typeface="Calibri"/>
               </a:rPr>
-              <a:t>Swopneel  ·  SDET</a:t>
+              <a:t>Swopneel</a:t>
+            </a:r>
+            <a:r>
+              <a:rPr sz="1050" b="1" dirty="0">
+                <a:solidFill>
+                  <a:srgbClr val="1A1A1A"/>
+                </a:solidFill>
+                <a:latin typeface="Calibri"/>
+              </a:rPr>
+              <a:t>  ·  SDET</a:t>
             </a:r>
           </a:p>
           <a:p>
@@ -4151,13 +4187,13 @@
               </a:spcAft>
             </a:pPr>
             <a:r>
-              <a:rPr sz="950" b="0">
+              <a:rPr sz="950" b="0" dirty="0">
                 <a:solidFill>
                   <a:srgbClr val="606676"/>
                 </a:solidFill>
                 <a:latin typeface="Calibri"/>
               </a:rPr>
-              <a:t>Harness, CI and contract tests · 1 May – 25 Aug</a:t>
+              <a:t>Harness, CI and contract tests </a:t>
             </a:r>
           </a:p>
         </p:txBody>
@@ -4179,7 +4215,7 @@
           <a:noFill/>
         </p:spPr>
         <p:txBody>
-          <a:bodyPr wrap="square" anchor="t" lIns="0" rIns="0" tIns="0" bIns="0">
+          <a:bodyPr wrap="square" lIns="0" tIns="0" rIns="0" bIns="0" anchor="t">
             <a:spAutoFit/>
           </a:bodyPr>
           <a:lstStyle/>
@@ -4218,7 +4254,7 @@
           <a:noFill/>
         </p:spPr>
         <p:txBody>
-          <a:bodyPr wrap="square" anchor="t" lIns="0" rIns="0" tIns="0" bIns="0">
+          <a:bodyPr wrap="square" lIns="0" tIns="0" rIns="0" bIns="0" anchor="t">
             <a:spAutoFit/>
           </a:bodyPr>
           <a:lstStyle/>
@@ -4249,7 +4285,7 @@
 </file>
 
 <file path=ppt/slides/slide2.xml><?xml version="1.0" encoding="utf-8"?>
-<p:sld xmlns:a="http://schemas.openxmlformats.org/drawingml/2006/main" xmlns:p="http://schemas.openxmlformats.org/presentationml/2006/main" xmlns:r="http://schemas.openxmlformats.org/officeDocument/2006/relationships">
+<p:sld xmlns:a="http://schemas.openxmlformats.org/drawingml/2006/main" xmlns:r="http://schemas.openxmlformats.org/officeDocument/2006/relationships" xmlns:p="http://schemas.openxmlformats.org/presentationml/2006/main">
   <p:cSld>
     <p:spTree>
       <p:nvGrpSpPr>
@@ -4257,7 +4293,14 @@
         <p:cNvGrpSpPr/>
         <p:nvPr/>
       </p:nvGrpSpPr>
-      <p:grpSpPr/>
+      <p:grpSpPr>
+        <a:xfrm>
+          <a:off x="0" y="0"/>
+          <a:ext cx="0" cy="0"/>
+          <a:chOff x="0" y="0"/>
+          <a:chExt cx="0" cy="0"/>
+        </a:xfrm>
+      </p:grpSpPr>
       <p:sp>
         <p:nvSpPr>
           <p:cNvPr id="2" name="Rectangle 1"/>
@@ -4299,6 +4342,7 @@
           <a:lstStyle/>
           <a:p>
             <a:pPr algn="ctr"/>
+            <a:endParaRPr/>
           </a:p>
         </p:txBody>
       </p:sp>
@@ -4319,7 +4363,7 @@
           <a:noFill/>
         </p:spPr>
         <p:txBody>
-          <a:bodyPr wrap="square" anchor="t" lIns="0" rIns="0" tIns="0" bIns="0">
+          <a:bodyPr wrap="square" lIns="0" tIns="0" rIns="0" bIns="0" anchor="t">
             <a:spAutoFit/>
           </a:bodyPr>
           <a:lstStyle/>
@@ -4358,7 +4402,7 @@
           <a:noFill/>
         </p:spPr>
         <p:txBody>
-          <a:bodyPr wrap="square" anchor="t" lIns="0" rIns="0" tIns="0" bIns="0">
+          <a:bodyPr wrap="square" lIns="0" tIns="0" rIns="0" bIns="0" anchor="t">
             <a:spAutoFit/>
           </a:bodyPr>
           <a:lstStyle/>
@@ -4421,6 +4465,7 @@
           <a:lstStyle/>
           <a:p>
             <a:pPr algn="ctr"/>
+            <a:endParaRPr/>
           </a:p>
         </p:txBody>
       </p:sp>
@@ -4441,7 +4486,7 @@
           <a:noFill/>
         </p:spPr>
         <p:txBody>
-          <a:bodyPr wrap="square" anchor="t" lIns="0" rIns="0" tIns="0" bIns="0">
+          <a:bodyPr wrap="square" lIns="0" tIns="0" rIns="0" bIns="0" anchor="t">
             <a:spAutoFit/>
           </a:bodyPr>
           <a:lstStyle/>
@@ -4504,6 +4549,7 @@
           <a:lstStyle/>
           <a:p>
             <a:pPr algn="ctr"/>
+            <a:endParaRPr/>
           </a:p>
         </p:txBody>
       </p:sp>
@@ -4548,6 +4594,7 @@
           <a:lstStyle/>
           <a:p>
             <a:pPr algn="ctr"/>
+            <a:endParaRPr/>
           </a:p>
         </p:txBody>
       </p:sp>
@@ -4568,7 +4615,7 @@
           <a:noFill/>
         </p:spPr>
         <p:txBody>
-          <a:bodyPr wrap="square" anchor="t" lIns="0" rIns="0" tIns="0" bIns="0">
+          <a:bodyPr wrap="square" lIns="0" tIns="0" rIns="0" bIns="0" anchor="t">
             <a:spAutoFit/>
           </a:bodyPr>
           <a:lstStyle/>
@@ -4607,7 +4654,7 @@
           <a:noFill/>
         </p:spPr>
         <p:txBody>
-          <a:bodyPr wrap="square" anchor="t" lIns="0" rIns="0" tIns="0" bIns="0">
+          <a:bodyPr wrap="square" lIns="0" tIns="0" rIns="0" bIns="0" anchor="t">
             <a:spAutoFit/>
           </a:bodyPr>
           <a:lstStyle/>
@@ -4646,7 +4693,7 @@
           <a:noFill/>
         </p:spPr>
         <p:txBody>
-          <a:bodyPr wrap="square" anchor="t" lIns="0" rIns="0" tIns="0" bIns="0">
+          <a:bodyPr wrap="square" lIns="0" tIns="0" rIns="0" bIns="0" anchor="t">
             <a:spAutoFit/>
           </a:bodyPr>
           <a:lstStyle/>
@@ -4685,7 +4732,7 @@
           <a:noFill/>
         </p:spPr>
         <p:txBody>
-          <a:bodyPr wrap="square" anchor="t" lIns="0" rIns="0" tIns="0" bIns="0">
+          <a:bodyPr wrap="square" lIns="0" tIns="0" rIns="0" bIns="0" anchor="t">
             <a:spAutoFit/>
           </a:bodyPr>
           <a:lstStyle/>
@@ -4748,6 +4795,7 @@
           <a:lstStyle/>
           <a:p>
             <a:pPr algn="ctr"/>
+            <a:endParaRPr/>
           </a:p>
         </p:txBody>
       </p:sp>
@@ -4792,6 +4840,7 @@
           <a:lstStyle/>
           <a:p>
             <a:pPr algn="ctr"/>
+            <a:endParaRPr/>
           </a:p>
         </p:txBody>
       </p:sp>
@@ -4812,7 +4861,7 @@
           <a:noFill/>
         </p:spPr>
         <p:txBody>
-          <a:bodyPr wrap="square" anchor="t" lIns="0" rIns="0" tIns="0" bIns="0">
+          <a:bodyPr wrap="square" lIns="0" tIns="0" rIns="0" bIns="0" anchor="t">
             <a:spAutoFit/>
           </a:bodyPr>
           <a:lstStyle/>
@@ -4851,7 +4900,7 @@
           <a:noFill/>
         </p:spPr>
         <p:txBody>
-          <a:bodyPr wrap="square" anchor="t" lIns="0" rIns="0" tIns="0" bIns="0">
+          <a:bodyPr wrap="square" lIns="0" tIns="0" rIns="0" bIns="0" anchor="t">
             <a:spAutoFit/>
           </a:bodyPr>
           <a:lstStyle/>
@@ -4890,7 +4939,7 @@
           <a:noFill/>
         </p:spPr>
         <p:txBody>
-          <a:bodyPr wrap="square" anchor="t" lIns="0" rIns="0" tIns="0" bIns="0">
+          <a:bodyPr wrap="square" lIns="0" tIns="0" rIns="0" bIns="0" anchor="t">
             <a:spAutoFit/>
           </a:bodyPr>
           <a:lstStyle/>
@@ -4929,7 +4978,7 @@
           <a:noFill/>
         </p:spPr>
         <p:txBody>
-          <a:bodyPr wrap="square" anchor="t" lIns="0" rIns="0" tIns="0" bIns="0">
+          <a:bodyPr wrap="square" lIns="0" tIns="0" rIns="0" bIns="0" anchor="t">
             <a:spAutoFit/>
           </a:bodyPr>
           <a:lstStyle/>
@@ -4992,6 +5041,7 @@
           <a:lstStyle/>
           <a:p>
             <a:pPr algn="ctr"/>
+            <a:endParaRPr/>
           </a:p>
         </p:txBody>
       </p:sp>
@@ -5036,6 +5086,7 @@
           <a:lstStyle/>
           <a:p>
             <a:pPr algn="ctr"/>
+            <a:endParaRPr/>
           </a:p>
         </p:txBody>
       </p:sp>
@@ -5056,7 +5107,7 @@
           <a:noFill/>
         </p:spPr>
         <p:txBody>
-          <a:bodyPr wrap="square" anchor="t" lIns="0" rIns="0" tIns="0" bIns="0">
+          <a:bodyPr wrap="square" lIns="0" tIns="0" rIns="0" bIns="0" anchor="t">
             <a:spAutoFit/>
           </a:bodyPr>
           <a:lstStyle/>
@@ -5095,7 +5146,7 @@
           <a:noFill/>
         </p:spPr>
         <p:txBody>
-          <a:bodyPr wrap="square" anchor="t" lIns="0" rIns="0" tIns="0" bIns="0">
+          <a:bodyPr wrap="square" lIns="0" tIns="0" rIns="0" bIns="0" anchor="t">
             <a:spAutoFit/>
           </a:bodyPr>
           <a:lstStyle/>
@@ -5134,7 +5185,7 @@
           <a:noFill/>
         </p:spPr>
         <p:txBody>
-          <a:bodyPr wrap="square" anchor="t" lIns="0" rIns="0" tIns="0" bIns="0">
+          <a:bodyPr wrap="square" lIns="0" tIns="0" rIns="0" bIns="0" anchor="t">
             <a:spAutoFit/>
           </a:bodyPr>
           <a:lstStyle/>
@@ -5173,7 +5224,7 @@
           <a:noFill/>
         </p:spPr>
         <p:txBody>
-          <a:bodyPr wrap="square" anchor="t" lIns="0" rIns="0" tIns="0" bIns="0">
+          <a:bodyPr wrap="square" lIns="0" tIns="0" rIns="0" bIns="0" anchor="t">
             <a:spAutoFit/>
           </a:bodyPr>
           <a:lstStyle/>
@@ -5236,6 +5287,7 @@
           <a:lstStyle/>
           <a:p>
             <a:pPr algn="ctr"/>
+            <a:endParaRPr/>
           </a:p>
         </p:txBody>
       </p:sp>
@@ -5280,6 +5332,7 @@
           <a:lstStyle/>
           <a:p>
             <a:pPr algn="ctr"/>
+            <a:endParaRPr/>
           </a:p>
         </p:txBody>
       </p:sp>
@@ -5300,7 +5353,7 @@
           <a:noFill/>
         </p:spPr>
         <p:txBody>
-          <a:bodyPr wrap="square" anchor="t" lIns="0" rIns="0" tIns="0" bIns="0">
+          <a:bodyPr wrap="square" lIns="0" tIns="0" rIns="0" bIns="0" anchor="t">
             <a:spAutoFit/>
           </a:bodyPr>
           <a:lstStyle/>
@@ -5339,7 +5392,7 @@
           <a:noFill/>
         </p:spPr>
         <p:txBody>
-          <a:bodyPr wrap="square" anchor="t" lIns="0" rIns="0" tIns="0" bIns="0">
+          <a:bodyPr wrap="square" lIns="0" tIns="0" rIns="0" bIns="0" anchor="t">
             <a:spAutoFit/>
           </a:bodyPr>
           <a:lstStyle/>
@@ -5378,7 +5431,7 @@
           <a:noFill/>
         </p:spPr>
         <p:txBody>
-          <a:bodyPr wrap="square" anchor="t" lIns="0" rIns="0" tIns="0" bIns="0">
+          <a:bodyPr wrap="square" lIns="0" tIns="0" rIns="0" bIns="0" anchor="t">
             <a:spAutoFit/>
           </a:bodyPr>
           <a:lstStyle/>
@@ -5417,7 +5470,7 @@
           <a:noFill/>
         </p:spPr>
         <p:txBody>
-          <a:bodyPr wrap="square" anchor="t" lIns="0" rIns="0" tIns="0" bIns="0">
+          <a:bodyPr wrap="square" lIns="0" tIns="0" rIns="0" bIns="0" anchor="t">
             <a:spAutoFit/>
           </a:bodyPr>
           <a:lstStyle/>
@@ -5480,6 +5533,7 @@
           <a:lstStyle/>
           <a:p>
             <a:pPr algn="ctr"/>
+            <a:endParaRPr/>
           </a:p>
         </p:txBody>
       </p:sp>
@@ -5524,6 +5578,7 @@
           <a:lstStyle/>
           <a:p>
             <a:pPr algn="ctr"/>
+            <a:endParaRPr/>
           </a:p>
         </p:txBody>
       </p:sp>
@@ -5544,7 +5599,7 @@
           <a:noFill/>
         </p:spPr>
         <p:txBody>
-          <a:bodyPr wrap="square" anchor="t" lIns="0" rIns="0" tIns="0" bIns="0">
+          <a:bodyPr wrap="square" lIns="0" tIns="0" rIns="0" bIns="0" anchor="t">
             <a:spAutoFit/>
           </a:bodyPr>
           <a:lstStyle/>
@@ -5583,7 +5638,7 @@
           <a:noFill/>
         </p:spPr>
         <p:txBody>
-          <a:bodyPr wrap="square" anchor="t" lIns="0" rIns="0" tIns="0" bIns="0">
+          <a:bodyPr wrap="square" lIns="0" tIns="0" rIns="0" bIns="0" anchor="t">
             <a:spAutoFit/>
           </a:bodyPr>
           <a:lstStyle/>
@@ -5622,7 +5677,7 @@
           <a:noFill/>
         </p:spPr>
         <p:txBody>
-          <a:bodyPr wrap="square" anchor="t" lIns="0" rIns="0" tIns="0" bIns="0">
+          <a:bodyPr wrap="square" lIns="0" tIns="0" rIns="0" bIns="0" anchor="t">
             <a:spAutoFit/>
           </a:bodyPr>
           <a:lstStyle/>
@@ -5661,7 +5716,7 @@
           <a:noFill/>
         </p:spPr>
         <p:txBody>
-          <a:bodyPr wrap="square" anchor="t" lIns="0" rIns="0" tIns="0" bIns="0">
+          <a:bodyPr wrap="square" lIns="0" tIns="0" rIns="0" bIns="0" anchor="t">
             <a:spAutoFit/>
           </a:bodyPr>
           <a:lstStyle/>
@@ -5724,6 +5779,7 @@
           <a:lstStyle/>
           <a:p>
             <a:pPr algn="ctr"/>
+            <a:endParaRPr/>
           </a:p>
         </p:txBody>
       </p:sp>
@@ -5768,6 +5824,7 @@
           <a:lstStyle/>
           <a:p>
             <a:pPr algn="ctr"/>
+            <a:endParaRPr/>
           </a:p>
         </p:txBody>
       </p:sp>
@@ -5788,7 +5845,7 @@
           <a:noFill/>
         </p:spPr>
         <p:txBody>
-          <a:bodyPr wrap="square" anchor="t" lIns="0" rIns="0" tIns="0" bIns="0">
+          <a:bodyPr wrap="square" lIns="0" tIns="0" rIns="0" bIns="0" anchor="t">
             <a:spAutoFit/>
           </a:bodyPr>
           <a:lstStyle/>
@@ -5827,7 +5884,7 @@
           <a:noFill/>
         </p:spPr>
         <p:txBody>
-          <a:bodyPr wrap="square" anchor="t" lIns="0" rIns="0" tIns="0" bIns="0">
+          <a:bodyPr wrap="square" lIns="0" tIns="0" rIns="0" bIns="0" anchor="t">
             <a:spAutoFit/>
           </a:bodyPr>
           <a:lstStyle/>
@@ -5866,7 +5923,7 @@
           <a:noFill/>
         </p:spPr>
         <p:txBody>
-          <a:bodyPr wrap="square" anchor="t" lIns="0" rIns="0" tIns="0" bIns="0">
+          <a:bodyPr wrap="square" lIns="0" tIns="0" rIns="0" bIns="0" anchor="t">
             <a:spAutoFit/>
           </a:bodyPr>
           <a:lstStyle/>
@@ -5905,7 +5962,7 @@
           <a:noFill/>
         </p:spPr>
         <p:txBody>
-          <a:bodyPr wrap="square" anchor="t" lIns="0" rIns="0" tIns="0" bIns="0">
+          <a:bodyPr wrap="square" lIns="0" tIns="0" rIns="0" bIns="0" anchor="t">
             <a:spAutoFit/>
           </a:bodyPr>
           <a:lstStyle/>
@@ -5968,6 +6025,7 @@
           <a:lstStyle/>
           <a:p>
             <a:pPr algn="ctr"/>
+            <a:endParaRPr/>
           </a:p>
         </p:txBody>
       </p:sp>
@@ -6012,6 +6070,7 @@
           <a:lstStyle/>
           <a:p>
             <a:pPr algn="ctr"/>
+            <a:endParaRPr/>
           </a:p>
         </p:txBody>
       </p:sp>
@@ -6032,7 +6091,7 @@
           <a:noFill/>
         </p:spPr>
         <p:txBody>
-          <a:bodyPr wrap="square" anchor="t" lIns="0" rIns="0" tIns="0" bIns="0">
+          <a:bodyPr wrap="square" lIns="0" tIns="0" rIns="0" bIns="0" anchor="t">
             <a:spAutoFit/>
           </a:bodyPr>
           <a:lstStyle/>
@@ -6071,7 +6130,7 @@
           <a:noFill/>
         </p:spPr>
         <p:txBody>
-          <a:bodyPr wrap="square" anchor="t" lIns="0" rIns="0" tIns="0" bIns="0">
+          <a:bodyPr wrap="square" lIns="0" tIns="0" rIns="0" bIns="0" anchor="t">
             <a:spAutoFit/>
           </a:bodyPr>
           <a:lstStyle/>
@@ -6110,7 +6169,7 @@
           <a:noFill/>
         </p:spPr>
         <p:txBody>
-          <a:bodyPr wrap="square" anchor="t" lIns="0" rIns="0" tIns="0" bIns="0">
+          <a:bodyPr wrap="square" lIns="0" tIns="0" rIns="0" bIns="0" anchor="t">
             <a:spAutoFit/>
           </a:bodyPr>
           <a:lstStyle/>
@@ -6149,7 +6208,7 @@
           <a:noFill/>
         </p:spPr>
         <p:txBody>
-          <a:bodyPr wrap="square" anchor="t" lIns="0" rIns="0" tIns="0" bIns="0">
+          <a:bodyPr wrap="square" lIns="0" tIns="0" rIns="0" bIns="0" anchor="t">
             <a:spAutoFit/>
           </a:bodyPr>
           <a:lstStyle/>
@@ -6212,6 +6271,7 @@
           <a:lstStyle/>
           <a:p>
             <a:pPr algn="ctr"/>
+            <a:endParaRPr/>
           </a:p>
         </p:txBody>
       </p:sp>
@@ -6256,6 +6316,7 @@
           <a:lstStyle/>
           <a:p>
             <a:pPr algn="ctr"/>
+            <a:endParaRPr/>
           </a:p>
         </p:txBody>
       </p:sp>
@@ -6276,7 +6337,7 @@
           <a:noFill/>
         </p:spPr>
         <p:txBody>
-          <a:bodyPr wrap="square" anchor="t" lIns="0" rIns="0" tIns="0" bIns="0">
+          <a:bodyPr wrap="square" lIns="0" tIns="0" rIns="0" bIns="0" anchor="t">
             <a:spAutoFit/>
           </a:bodyPr>
           <a:lstStyle/>
@@ -6315,7 +6376,7 @@
           <a:noFill/>
         </p:spPr>
         <p:txBody>
-          <a:bodyPr wrap="square" anchor="t" lIns="0" rIns="0" tIns="0" bIns="0">
+          <a:bodyPr wrap="square" lIns="0" tIns="0" rIns="0" bIns="0" anchor="t">
             <a:spAutoFit/>
           </a:bodyPr>
           <a:lstStyle/>
@@ -6354,7 +6415,7 @@
           <a:noFill/>
         </p:spPr>
         <p:txBody>
-          <a:bodyPr wrap="square" anchor="t" lIns="0" rIns="0" tIns="0" bIns="0">
+          <a:bodyPr wrap="square" lIns="0" tIns="0" rIns="0" bIns="0" anchor="t">
             <a:spAutoFit/>
           </a:bodyPr>
           <a:lstStyle/>
@@ -6393,7 +6454,7 @@
           <a:noFill/>
         </p:spPr>
         <p:txBody>
-          <a:bodyPr wrap="square" anchor="t" lIns="0" rIns="0" tIns="0" bIns="0">
+          <a:bodyPr wrap="square" lIns="0" tIns="0" rIns="0" bIns="0" anchor="t">
             <a:spAutoFit/>
           </a:bodyPr>
           <a:lstStyle/>
@@ -6432,7 +6493,7 @@
           <a:noFill/>
         </p:spPr>
         <p:txBody>
-          <a:bodyPr wrap="square" anchor="t" lIns="0" rIns="0" tIns="0" bIns="0">
+          <a:bodyPr wrap="square" lIns="0" tIns="0" rIns="0" bIns="0" anchor="t">
             <a:spAutoFit/>
           </a:bodyPr>
           <a:lstStyle/>
@@ -6471,7 +6532,7 @@
           <a:noFill/>
         </p:spPr>
         <p:txBody>
-          <a:bodyPr wrap="square" anchor="t" lIns="0" rIns="0" tIns="0" bIns="0">
+          <a:bodyPr wrap="square" lIns="0" tIns="0" rIns="0" bIns="0" anchor="t">
             <a:spAutoFit/>
           </a:bodyPr>
           <a:lstStyle/>
@@ -6510,7 +6571,7 @@
           <a:noFill/>
         </p:spPr>
         <p:txBody>
-          <a:bodyPr wrap="square" anchor="t" lIns="0" rIns="0" tIns="0" bIns="0">
+          <a:bodyPr wrap="square" lIns="0" tIns="0" rIns="0" bIns="0" anchor="t">
             <a:spAutoFit/>
           </a:bodyPr>
           <a:lstStyle/>
@@ -6541,7 +6602,7 @@
 </file>
 
 <file path=ppt/slides/slide3.xml><?xml version="1.0" encoding="utf-8"?>
-<p:sld xmlns:a="http://schemas.openxmlformats.org/drawingml/2006/main" xmlns:p="http://schemas.openxmlformats.org/presentationml/2006/main" xmlns:r="http://schemas.openxmlformats.org/officeDocument/2006/relationships">
+<p:sld xmlns:a="http://schemas.openxmlformats.org/drawingml/2006/main" xmlns:r="http://schemas.openxmlformats.org/officeDocument/2006/relationships" xmlns:p="http://schemas.openxmlformats.org/presentationml/2006/main">
   <p:cSld>
     <p:spTree>
       <p:nvGrpSpPr>
@@ -6549,7 +6610,14 @@
         <p:cNvGrpSpPr/>
         <p:nvPr/>
       </p:nvGrpSpPr>
-      <p:grpSpPr/>
+      <p:grpSpPr>
+        <a:xfrm>
+          <a:off x="0" y="0"/>
+          <a:ext cx="0" cy="0"/>
+          <a:chOff x="0" y="0"/>
+          <a:chExt cx="0" cy="0"/>
+        </a:xfrm>
+      </p:grpSpPr>
       <p:sp>
         <p:nvSpPr>
           <p:cNvPr id="2" name="Rectangle 1"/>
@@ -6591,6 +6659,7 @@
           <a:lstStyle/>
           <a:p>
             <a:pPr algn="ctr"/>
+            <a:endParaRPr/>
           </a:p>
         </p:txBody>
       </p:sp>
@@ -6611,7 +6680,7 @@
           <a:noFill/>
         </p:spPr>
         <p:txBody>
-          <a:bodyPr wrap="square" anchor="t" lIns="0" rIns="0" tIns="0" bIns="0">
+          <a:bodyPr wrap="square" lIns="0" tIns="0" rIns="0" bIns="0" anchor="t">
             <a:spAutoFit/>
           </a:bodyPr>
           <a:lstStyle/>
@@ -6650,7 +6719,7 @@
           <a:noFill/>
         </p:spPr>
         <p:txBody>
-          <a:bodyPr wrap="square" anchor="t" lIns="0" rIns="0" tIns="0" bIns="0">
+          <a:bodyPr wrap="square" lIns="0" tIns="0" rIns="0" bIns="0" anchor="t">
             <a:spAutoFit/>
           </a:bodyPr>
           <a:lstStyle/>
@@ -6713,6 +6782,7 @@
           <a:lstStyle/>
           <a:p>
             <a:pPr algn="ctr"/>
+            <a:endParaRPr/>
           </a:p>
         </p:txBody>
       </p:sp>
@@ -6733,7 +6803,7 @@
           <a:noFill/>
         </p:spPr>
         <p:txBody>
-          <a:bodyPr wrap="square" anchor="t" lIns="0" rIns="0" tIns="0" bIns="0">
+          <a:bodyPr wrap="square" lIns="0" tIns="0" rIns="0" bIns="0" anchor="t">
             <a:spAutoFit/>
           </a:bodyPr>
           <a:lstStyle/>
@@ -6796,6 +6866,7 @@
           <a:lstStyle/>
           <a:p>
             <a:pPr algn="ctr"/>
+            <a:endParaRPr/>
           </a:p>
         </p:txBody>
       </p:sp>
@@ -6840,6 +6911,7 @@
           <a:lstStyle/>
           <a:p>
             <a:pPr algn="ctr"/>
+            <a:endParaRPr/>
           </a:p>
         </p:txBody>
       </p:sp>
@@ -6860,7 +6932,7 @@
           <a:noFill/>
         </p:spPr>
         <p:txBody>
-          <a:bodyPr wrap="square" anchor="t" lIns="0" rIns="0" tIns="0" bIns="0">
+          <a:bodyPr wrap="square" lIns="0" tIns="0" rIns="0" bIns="0" anchor="t">
             <a:spAutoFit/>
           </a:bodyPr>
           <a:lstStyle/>
@@ -6871,7 +6943,7 @@
               </a:spcAft>
             </a:pPr>
             <a:r>
-              <a:rPr sz="1300" b="1">
+              <a:rPr sz="1300" b="1" dirty="0">
                 <a:solidFill>
                   <a:srgbClr val="003654"/>
                 </a:solidFill>
@@ -6887,7 +6959,7 @@
               </a:spcAft>
             </a:pPr>
             <a:r>
-              <a:rPr sz="1050" b="0">
+              <a:rPr sz="1050" b="0" dirty="0">
                 <a:solidFill>
                   <a:srgbClr val="1A1A1A"/>
                 </a:solidFill>
@@ -6903,7 +6975,7 @@
               </a:spcAft>
             </a:pPr>
             <a:r>
-              <a:rPr sz="1050" b="0">
+              <a:rPr sz="1050" b="0" dirty="0">
                 <a:solidFill>
                   <a:srgbClr val="1A1A1A"/>
                 </a:solidFill>
@@ -6919,7 +6991,7 @@
               </a:spcAft>
             </a:pPr>
             <a:r>
-              <a:rPr sz="1050" b="0">
+              <a:rPr sz="1050" b="0" dirty="0">
                 <a:solidFill>
                   <a:srgbClr val="1A1A1A"/>
                 </a:solidFill>
@@ -6971,6 +7043,7 @@
           <a:lstStyle/>
           <a:p>
             <a:pPr algn="ctr"/>
+            <a:endParaRPr/>
           </a:p>
         </p:txBody>
       </p:sp>
@@ -7015,6 +7088,7 @@
           <a:lstStyle/>
           <a:p>
             <a:pPr algn="ctr"/>
+            <a:endParaRPr/>
           </a:p>
         </p:txBody>
       </p:sp>
@@ -7035,7 +7109,7 @@
           <a:noFill/>
         </p:spPr>
         <p:txBody>
-          <a:bodyPr wrap="square" anchor="t" lIns="0" rIns="0" tIns="0" bIns="0">
+          <a:bodyPr wrap="square" lIns="0" tIns="0" rIns="0" bIns="0" anchor="t">
             <a:spAutoFit/>
           </a:bodyPr>
           <a:lstStyle/>
@@ -7046,7 +7120,7 @@
               </a:spcAft>
             </a:pPr>
             <a:r>
-              <a:rPr sz="1300" b="1">
+              <a:rPr sz="1300" b="1" dirty="0">
                 <a:solidFill>
                   <a:srgbClr val="003654"/>
                 </a:solidFill>
@@ -7062,7 +7136,7 @@
               </a:spcAft>
             </a:pPr>
             <a:r>
-              <a:rPr sz="1050" b="0">
+              <a:rPr sz="1050" b="0" dirty="0">
                 <a:solidFill>
                   <a:srgbClr val="1A1A1A"/>
                 </a:solidFill>
@@ -7078,7 +7152,7 @@
               </a:spcAft>
             </a:pPr>
             <a:r>
-              <a:rPr sz="1050" b="0">
+              <a:rPr sz="1050" b="0" dirty="0">
                 <a:solidFill>
                   <a:srgbClr val="1A1A1A"/>
                 </a:solidFill>
@@ -7094,7 +7168,7 @@
               </a:spcAft>
             </a:pPr>
             <a:r>
-              <a:rPr sz="1050" b="0">
+              <a:rPr sz="1050" b="0" dirty="0">
                 <a:solidFill>
                   <a:srgbClr val="1A1A1A"/>
                 </a:solidFill>
@@ -7146,6 +7220,7 @@
           <a:lstStyle/>
           <a:p>
             <a:pPr algn="ctr"/>
+            <a:endParaRPr dirty="0"/>
           </a:p>
         </p:txBody>
       </p:sp>
@@ -7190,6 +7265,7 @@
           <a:lstStyle/>
           <a:p>
             <a:pPr algn="ctr"/>
+            <a:endParaRPr/>
           </a:p>
         </p:txBody>
       </p:sp>
@@ -7210,7 +7286,7 @@
           <a:noFill/>
         </p:spPr>
         <p:txBody>
-          <a:bodyPr wrap="square" anchor="t" lIns="0" rIns="0" tIns="0" bIns="0">
+          <a:bodyPr wrap="square" lIns="0" tIns="0" rIns="0" bIns="0" anchor="t">
             <a:spAutoFit/>
           </a:bodyPr>
           <a:lstStyle/>
@@ -7221,7 +7297,7 @@
               </a:spcAft>
             </a:pPr>
             <a:r>
-              <a:rPr sz="1300" b="1">
+              <a:rPr sz="1300" b="1" dirty="0">
                 <a:solidFill>
                   <a:srgbClr val="003654"/>
                 </a:solidFill>
@@ -7237,7 +7313,7 @@
               </a:spcAft>
             </a:pPr>
             <a:r>
-              <a:rPr sz="1050" b="0">
+              <a:rPr sz="1050" b="0" dirty="0">
                 <a:solidFill>
                   <a:srgbClr val="1A1A1A"/>
                 </a:solidFill>
@@ -7253,7 +7329,7 @@
               </a:spcAft>
             </a:pPr>
             <a:r>
-              <a:rPr sz="1050" b="0">
+              <a:rPr sz="1050" b="0" dirty="0">
                 <a:solidFill>
                   <a:srgbClr val="1A1A1A"/>
                 </a:solidFill>
@@ -7269,7 +7345,7 @@
               </a:spcAft>
             </a:pPr>
             <a:r>
-              <a:rPr sz="1050" b="0">
+              <a:rPr sz="1050" b="0" dirty="0">
                 <a:solidFill>
                   <a:srgbClr val="1A1A1A"/>
                 </a:solidFill>
@@ -7323,6 +7399,7 @@
           <a:lstStyle/>
           <a:p>
             <a:pPr algn="ctr"/>
+            <a:endParaRPr/>
           </a:p>
         </p:txBody>
       </p:sp>
@@ -7343,7 +7420,7 @@
           <a:noFill/>
         </p:spPr>
         <p:txBody>
-          <a:bodyPr wrap="square" anchor="t" lIns="0" rIns="0" tIns="0" bIns="0">
+          <a:bodyPr wrap="square" lIns="0" tIns="0" rIns="0" bIns="0" anchor="t">
             <a:spAutoFit/>
           </a:bodyPr>
           <a:lstStyle/>
@@ -7398,7 +7475,7 @@
           <a:noFill/>
         </p:spPr>
         <p:txBody>
-          <a:bodyPr wrap="square" anchor="t" lIns="0" rIns="0" tIns="0" bIns="0">
+          <a:bodyPr wrap="square" lIns="0" tIns="0" rIns="0" bIns="0" anchor="t">
             <a:spAutoFit/>
           </a:bodyPr>
           <a:lstStyle/>
@@ -7437,7 +7514,7 @@
           <a:noFill/>
         </p:spPr>
         <p:txBody>
-          <a:bodyPr wrap="square" anchor="t" lIns="0" rIns="0" tIns="0" bIns="0">
+          <a:bodyPr wrap="square" lIns="0" tIns="0" rIns="0" bIns="0" anchor="t">
             <a:spAutoFit/>
           </a:bodyPr>
           <a:lstStyle/>
@@ -7468,7 +7545,7 @@
 </file>
 
 <file path=ppt/slides/slide4.xml><?xml version="1.0" encoding="utf-8"?>
-<p:sld xmlns:a="http://schemas.openxmlformats.org/drawingml/2006/main" xmlns:p="http://schemas.openxmlformats.org/presentationml/2006/main" xmlns:r="http://schemas.openxmlformats.org/officeDocument/2006/relationships">
+<p:sld xmlns:a="http://schemas.openxmlformats.org/drawingml/2006/main" xmlns:r="http://schemas.openxmlformats.org/officeDocument/2006/relationships" xmlns:p="http://schemas.openxmlformats.org/presentationml/2006/main">
   <p:cSld>
     <p:spTree>
       <p:nvGrpSpPr>
@@ -7476,7 +7553,14 @@
         <p:cNvGrpSpPr/>
         <p:nvPr/>
       </p:nvGrpSpPr>
-      <p:grpSpPr/>
+      <p:grpSpPr>
+        <a:xfrm>
+          <a:off x="0" y="0"/>
+          <a:ext cx="0" cy="0"/>
+          <a:chOff x="0" y="0"/>
+          <a:chExt cx="0" cy="0"/>
+        </a:xfrm>
+      </p:grpSpPr>
       <p:sp>
         <p:nvSpPr>
           <p:cNvPr id="2" name="Rectangle 1"/>
@@ -7518,6 +7602,7 @@
           <a:lstStyle/>
           <a:p>
             <a:pPr algn="ctr"/>
+            <a:endParaRPr/>
           </a:p>
         </p:txBody>
       </p:sp>
@@ -7538,7 +7623,7 @@
           <a:noFill/>
         </p:spPr>
         <p:txBody>
-          <a:bodyPr wrap="square" anchor="t" lIns="0" rIns="0" tIns="0" bIns="0">
+          <a:bodyPr wrap="square" lIns="0" tIns="0" rIns="0" bIns="0" anchor="t">
             <a:spAutoFit/>
           </a:bodyPr>
           <a:lstStyle/>
@@ -7577,7 +7662,7 @@
           <a:noFill/>
         </p:spPr>
         <p:txBody>
-          <a:bodyPr wrap="square" anchor="t" lIns="0" rIns="0" tIns="0" bIns="0">
+          <a:bodyPr wrap="square" lIns="0" tIns="0" rIns="0" bIns="0" anchor="t">
             <a:spAutoFit/>
           </a:bodyPr>
           <a:lstStyle/>
@@ -7640,6 +7725,7 @@
           <a:lstStyle/>
           <a:p>
             <a:pPr algn="ctr"/>
+            <a:endParaRPr/>
           </a:p>
         </p:txBody>
       </p:sp>
@@ -7660,7 +7746,7 @@
           <a:noFill/>
         </p:spPr>
         <p:txBody>
-          <a:bodyPr wrap="square" anchor="t" lIns="0" rIns="0" tIns="0" bIns="0">
+          <a:bodyPr wrap="square" lIns="0" tIns="0" rIns="0" bIns="0" anchor="t">
             <a:spAutoFit/>
           </a:bodyPr>
           <a:lstStyle/>
@@ -7725,6 +7811,7 @@
           <a:lstStyle/>
           <a:p>
             <a:pPr algn="ctr"/>
+            <a:endParaRPr/>
           </a:p>
         </p:txBody>
       </p:sp>
@@ -7769,6 +7856,7 @@
           <a:lstStyle/>
           <a:p>
             <a:pPr algn="ctr"/>
+            <a:endParaRPr/>
           </a:p>
         </p:txBody>
       </p:sp>
@@ -7789,7 +7877,7 @@
           <a:noFill/>
         </p:spPr>
         <p:txBody>
-          <a:bodyPr wrap="square" anchor="t" lIns="0" rIns="0" tIns="0" bIns="0">
+          <a:bodyPr wrap="square" lIns="0" tIns="0" rIns="0" bIns="0" anchor="t">
             <a:spAutoFit/>
           </a:bodyPr>
           <a:lstStyle/>
@@ -7828,7 +7916,7 @@
           <a:noFill/>
         </p:spPr>
         <p:txBody>
-          <a:bodyPr wrap="square" anchor="t" lIns="0" rIns="0" tIns="0" bIns="0">
+          <a:bodyPr wrap="square" lIns="0" tIns="0" rIns="0" bIns="0" anchor="t">
             <a:spAutoFit/>
           </a:bodyPr>
           <a:lstStyle/>
@@ -7925,6 +8013,7 @@
           <a:lstStyle/>
           <a:p>
             <a:pPr algn="ctr"/>
+            <a:endParaRPr/>
           </a:p>
         </p:txBody>
       </p:sp>
@@ -7969,6 +8058,7 @@
           <a:lstStyle/>
           <a:p>
             <a:pPr algn="ctr"/>
+            <a:endParaRPr/>
           </a:p>
         </p:txBody>
       </p:sp>
@@ -7989,7 +8079,7 @@
           <a:noFill/>
         </p:spPr>
         <p:txBody>
-          <a:bodyPr wrap="square" anchor="t" lIns="0" rIns="0" tIns="0" bIns="0">
+          <a:bodyPr wrap="square" lIns="0" tIns="0" rIns="0" bIns="0" anchor="t">
             <a:spAutoFit/>
           </a:bodyPr>
           <a:lstStyle/>
@@ -8028,7 +8118,7 @@
           <a:noFill/>
         </p:spPr>
         <p:txBody>
-          <a:bodyPr wrap="square" anchor="t" lIns="0" rIns="0" tIns="0" bIns="0">
+          <a:bodyPr wrap="square" lIns="0" tIns="0" rIns="0" bIns="0" anchor="t">
             <a:spAutoFit/>
           </a:bodyPr>
           <a:lstStyle/>
@@ -8125,6 +8215,7 @@
           <a:lstStyle/>
           <a:p>
             <a:pPr algn="ctr"/>
+            <a:endParaRPr/>
           </a:p>
         </p:txBody>
       </p:sp>
@@ -8169,6 +8260,7 @@
           <a:lstStyle/>
           <a:p>
             <a:pPr algn="ctr"/>
+            <a:endParaRPr/>
           </a:p>
         </p:txBody>
       </p:sp>
@@ -8189,7 +8281,7 @@
           <a:noFill/>
         </p:spPr>
         <p:txBody>
-          <a:bodyPr wrap="square" anchor="t" lIns="0" rIns="0" tIns="0" bIns="0">
+          <a:bodyPr wrap="square" lIns="0" tIns="0" rIns="0" bIns="0" anchor="t">
             <a:spAutoFit/>
           </a:bodyPr>
           <a:lstStyle/>
@@ -8228,7 +8320,7 @@
           <a:noFill/>
         </p:spPr>
         <p:txBody>
-          <a:bodyPr wrap="square" anchor="t" lIns="0" rIns="0" tIns="0" bIns="0">
+          <a:bodyPr wrap="square" lIns="0" tIns="0" rIns="0" bIns="0" anchor="t">
             <a:spAutoFit/>
           </a:bodyPr>
           <a:lstStyle/>
@@ -8323,6 +8415,7 @@
           <a:lstStyle/>
           <a:p>
             <a:pPr algn="ctr"/>
+            <a:endParaRPr/>
           </a:p>
         </p:txBody>
       </p:sp>
@@ -8343,7 +8436,7 @@
           <a:noFill/>
         </p:spPr>
         <p:txBody>
-          <a:bodyPr wrap="square" anchor="t" lIns="0" rIns="0" tIns="0" bIns="0">
+          <a:bodyPr wrap="square" lIns="0" tIns="0" rIns="0" bIns="0" anchor="t">
             <a:spAutoFit/>
           </a:bodyPr>
           <a:lstStyle/>
@@ -8398,7 +8491,7 @@
           <a:noFill/>
         </p:spPr>
         <p:txBody>
-          <a:bodyPr wrap="square" anchor="t" lIns="0" rIns="0" tIns="0" bIns="0">
+          <a:bodyPr wrap="square" lIns="0" tIns="0" rIns="0" bIns="0" anchor="t">
             <a:spAutoFit/>
           </a:bodyPr>
           <a:lstStyle/>
@@ -8437,7 +8530,7 @@
           <a:noFill/>
         </p:spPr>
         <p:txBody>
-          <a:bodyPr wrap="square" anchor="t" lIns="0" rIns="0" tIns="0" bIns="0">
+          <a:bodyPr wrap="square" lIns="0" tIns="0" rIns="0" bIns="0" anchor="t">
             <a:spAutoFit/>
           </a:bodyPr>
           <a:lstStyle/>

</xml_diff>